<commit_message>
test: refresh canonical NodeSlide proof
</commit_message>
<xml_diff>
--- a/docs/dogfood/nodeslide-domain-v1/nodeslide-golden.pptx
+++ b/docs/dogfood/nodeslide-domain-v1/nodeslide-golden.pptx
@@ -511,7 +511,7 @@
               <a:t>Narrative role: NodeSlide / 01. Keep the spoken transition focused on “Build the story. Keep every decision editable.”
 Evidence note: Content is based on the supplied creation brief. Illustrative examples are not independently verified; replace them with measured evidence before external publication.
 NodeSlide sources
-[source_01o5drc] NodeSlide product brief
+[source_96a6a42be4bdf0cef8b6f3f8c453dbfb] NodeSlide product brief
 Citation: Show how NodeSlide turns presentation work into a traceable, editable, reviewable system.
 Disclaimer: Internal working material</a:t>
             </a:r>
@@ -604,10 +604,10 @@
               <a:t>Narrative role: Scenario / 02. Keep the spoken transition focused on “Keep source context attached as the story moves.”
 Evidence note: Content is based on the supplied creation brief. Illustrative examples are not independently verified; replace them with measured evidence before external publication.
 NodeSlide sources
-[source_01o5drc] NodeSlide product brief
+[source_96a6a42be4bdf0cef8b6f3f8c453dbfb] NodeSlide product brief
 Citation: Show how NodeSlide turns presentation work into a traceable, editable, reviewable system.
 Disclaimer: Internal working material
-[source_1vu07vp] Golden workflow scenario
+[source_af6acf1aa730a0e091a9f391a61fcd2d] Golden workflow scenario
 Citation: Qualitative product-workflow scenario for demonstrating NodeSlide; no measured customer benchmark is claimed.
 Disclaimer: Internal working material</a:t>
             </a:r>
@@ -700,7 +700,7 @@
               <a:t>Narrative role: Foundation / 03. Keep the spoken transition focused on “Structure turns a visual artifact into an operating surface.”
 Evidence note: Content is based on the supplied creation brief. Illustrative examples are not independently verified; replace them with measured evidence before external publication.
 NodeSlide sources
-[source_01o5drc] NodeSlide product brief
+[source_96a6a42be4bdf0cef8b6f3f8c453dbfb] NodeSlide product brief
 Citation: Show how NodeSlide turns presentation work into a traceable, editable, reviewable system.
 Disclaimer: Internal working material</a:t>
             </a:r>
@@ -793,7 +793,7 @@
               <a:t>Narrative role: Workflow / 04. Keep the spoken transition focused on “Plan → propose → commit, with scope checked at every boundary.”
 Evidence note: Content is based on the supplied creation brief. Illustrative examples are not independently verified; replace them with measured evidence before external publication.
 NodeSlide sources
-[source_01o5drc] NodeSlide product brief
+[source_96a6a42be4bdf0cef8b6f3f8c453dbfb] NodeSlide product brief
 Citation: Show how NodeSlide turns presentation work into a traceable, editable, reviewable system.
 Disclaimer: Internal working material</a:t>
             </a:r>
@@ -886,10 +886,10 @@
               <a:t>Narrative role: Proof / 05. Keep the spoken transition focused on “A beautiful deck still needs deterministic gates.”
 Evidence note: Content is based on the supplied creation brief. Illustrative examples are not independently verified; replace them with measured evidence before external publication.
 NodeSlide sources
-[source_01o5drc] NodeSlide product brief
+[source_96a6a42be4bdf0cef8b6f3f8c453dbfb] NodeSlide product brief
 Citation: Show how NodeSlide turns presentation work into a traceable, editable, reviewable system.
 Disclaimer: Internal working material
-[source_1vu07vp] Golden workflow scenario
+[source_af6acf1aa730a0e091a9f391a61fcd2d] Golden workflow scenario
 Citation: Qualitative product-workflow scenario for demonstrating NodeSlide; no measured customer benchmark is claimed.
 Disclaimer: Internal working material</a:t>
             </a:r>
@@ -982,7 +982,7 @@
               <a:t>Narrative role: Trust / 06. Keep the spoken transition focused on “Comments become context. Patches remain choices.”
 Evidence note: Content is based on the supplied creation brief. Illustrative examples are not independently verified; replace them with measured evidence before external publication.
 NodeSlide sources
-[source_01o5drc] NodeSlide product brief
+[source_96a6a42be4bdf0cef8b6f3f8c453dbfb] NodeSlide product brief
 Citation: Show how NodeSlide turns presentation work into a traceable, editable, reviewable system.
 Disclaimer: Internal working material</a:t>
             </a:r>
@@ -1075,7 +1075,7 @@
               <a:t>Narrative role: Next / 07. Keep the spoken transition focused on “Move at presentation speed without giving up engineering-grade trust.”
 Evidence note: Content is based on the supplied creation brief. Illustrative examples are not independently verified; replace them with measured evidence before external publication.
 NodeSlide sources
-[source_01o5drc] NodeSlide product brief
+[source_96a6a42be4bdf0cef8b6f3f8c453dbfb] NodeSlide product brief
 Citation: Show how NodeSlide turns presentation work into a traceable, editable, reviewable system.
 Disclaimer: Internal working material</a:t>
             </a:r>
@@ -1452,7 +1452,7 @@
       </p:grpSpPr>
       <p:sp>
         <p:nvSpPr>
-          <p:cNvPr id="2" name="element_14ye96s"/>
+          <p:cNvPr id="2" name="element_370ba551ddbd0662d7fc04acd744609e"/>
           <p:cNvSpPr/>
           <p:nvPr/>
         </p:nvSpPr>
@@ -1479,7 +1479,7 @@
       </p:sp>
       <p:sp>
         <p:nvSpPr>
-          <p:cNvPr id="3" name="element_05vc09q"/>
+          <p:cNvPr id="3" name="element_2a17a5661c042a04a73ecdc0813e2cdb"/>
           <p:cNvSpPr txBox="1"/>
           <p:nvPr/>
         </p:nvSpPr>
@@ -1523,7 +1523,7 @@
       </p:sp>
       <p:sp>
         <p:nvSpPr>
-          <p:cNvPr id="4" name="element_1bytkp7"/>
+          <p:cNvPr id="4" name="element_61ee0f53c258556cd84cfd7bac8aae3a"/>
           <p:cNvSpPr txBox="1"/>
           <p:nvPr/>
         </p:nvSpPr>
@@ -1567,7 +1567,7 @@
       </p:sp>
       <p:sp>
         <p:nvSpPr>
-          <p:cNvPr id="5" name="element_0bhdbpv"/>
+          <p:cNvPr id="5" name="element_889fb4fc4d96b7c0851e9fcfd46a6bdc"/>
           <p:cNvSpPr txBox="1"/>
           <p:nvPr/>
         </p:nvSpPr>
@@ -1611,7 +1611,7 @@
       </p:sp>
       <p:sp>
         <p:nvSpPr>
-          <p:cNvPr id="6" name="element_1eqxy61"/>
+          <p:cNvPr id="6" name="element_640b14d5f6930f912de30905268178b8"/>
           <p:cNvSpPr txBox="1"/>
           <p:nvPr/>
         </p:nvSpPr>
@@ -1655,7 +1655,7 @@
       </p:sp>
       <p:sp>
         <p:nvSpPr>
-          <p:cNvPr id="7" name="element_1dwz534"/>
+          <p:cNvPr id="7" name="element_c26b53ad82326babcb864b1713b5a8f0"/>
           <p:cNvSpPr txBox="1"/>
           <p:nvPr/>
         </p:nvSpPr>
@@ -1699,7 +1699,7 @@
       </p:sp>
       <p:sp>
         <p:nvSpPr>
-          <p:cNvPr id="8" name="element_1e6yqs3"/>
+          <p:cNvPr id="8" name="element_8ea417e51d2186a7e95e517038fc0b91"/>
           <p:cNvSpPr txBox="1"/>
           <p:nvPr/>
         </p:nvSpPr>
@@ -1743,7 +1743,7 @@
       </p:sp>
       <p:sp>
         <p:nvSpPr>
-          <p:cNvPr id="9" name="element_17g0fj4"/>
+          <p:cNvPr id="9" name="element_a3e163e2e0e15fdee5f2c6cabeec87c5"/>
           <p:cNvSpPr txBox="1"/>
           <p:nvPr/>
         </p:nvSpPr>
@@ -1787,7 +1787,7 @@
       </p:sp>
       <p:sp>
         <p:nvSpPr>
-          <p:cNvPr id="10" name="element_0496nna"/>
+          <p:cNvPr id="10" name="element_9f8bf6a787f0475c7a366fd188ce022e"/>
           <p:cNvSpPr txBox="1"/>
           <p:nvPr/>
         </p:nvSpPr>
@@ -1863,7 +1863,7 @@
       </p:grpSpPr>
       <p:sp>
         <p:nvSpPr>
-          <p:cNvPr id="2" name="element_19ntmqs"/>
+          <p:cNvPr id="2" name="element_0323b6c8041a56d2e1a0f15fa191f2d0"/>
           <p:cNvSpPr/>
           <p:nvPr/>
         </p:nvSpPr>
@@ -1890,7 +1890,7 @@
       </p:sp>
       <p:sp>
         <p:nvSpPr>
-          <p:cNvPr id="3" name="element_0ghktha"/>
+          <p:cNvPr id="3" name="element_4b4d1dc69245682e345b15e626972fd9"/>
           <p:cNvSpPr txBox="1"/>
           <p:nvPr/>
         </p:nvSpPr>
@@ -1934,7 +1934,7 @@
       </p:sp>
       <p:sp>
         <p:nvSpPr>
-          <p:cNvPr id="4" name="element_1igwodn"/>
+          <p:cNvPr id="4" name="element_789778442a6ae438cd0ecb197d98edaf"/>
           <p:cNvSpPr txBox="1"/>
           <p:nvPr/>
         </p:nvSpPr>
@@ -1978,7 +1978,7 @@
       </p:sp>
       <p:sp>
         <p:nvSpPr>
-          <p:cNvPr id="5" name="element_0i6r377"/>
+          <p:cNvPr id="5" name="element_f995c27b8b789b00520e356587acd4f5"/>
           <p:cNvSpPr txBox="1"/>
           <p:nvPr/>
         </p:nvSpPr>
@@ -2022,7 +2022,7 @@
       </p:sp>
       <p:sp>
         <p:nvSpPr>
-          <p:cNvPr id="6" name="element_0a2msux"/>
+          <p:cNvPr id="6" name="element_ec3dd98375c7ad4afedf99c4c93224c9"/>
           <p:cNvSpPr txBox="1"/>
           <p:nvPr/>
         </p:nvSpPr>
@@ -2066,7 +2066,7 @@
       </p:sp>
       <p:sp>
         <p:nvSpPr>
-          <p:cNvPr id="7" name="element_098nzs0"/>
+          <p:cNvPr id="7" name="element_d78f82eb60b33b82068b8455e74a04e7"/>
           <p:cNvSpPr txBox="1"/>
           <p:nvPr/>
         </p:nvSpPr>
@@ -2110,7 +2110,7 @@
       </p:sp>
       <p:sp>
         <p:nvSpPr>
-          <p:cNvPr id="8" name="element_09inlgz"/>
+          <p:cNvPr id="8" name="element_a7d2620b40de0c871dfe92184d50a0da"/>
           <p:cNvSpPr txBox="1"/>
           <p:nvPr/>
         </p:nvSpPr>
@@ -2154,7 +2154,7 @@
       </p:sp>
       <p:sp>
         <p:nvSpPr>
-          <p:cNvPr id="9" name="element_1u12qon"/>
+          <p:cNvPr id="9" name="element_bec6c837aaac7a129e0d827ac1c37b61"/>
           <p:cNvSpPr txBox="1"/>
           <p:nvPr/>
         </p:nvSpPr>
@@ -2198,7 +2198,7 @@
       </p:sp>
       <p:sp>
         <p:nvSpPr>
-          <p:cNvPr id="10" name="element_1deh10k"/>
+          <p:cNvPr id="10" name="element_58305a50bc1379606692fa40c8a074f7"/>
           <p:cNvSpPr txBox="1"/>
           <p:nvPr/>
         </p:nvSpPr>
@@ -2242,7 +2242,7 @@
       </p:sp>
       <p:sp>
         <p:nvSpPr>
-          <p:cNvPr id="11" name="element_0im6dq8"/>
+          <p:cNvPr id="11" name="element_49bbb381be7ee11d3d18ed0dc590f285"/>
           <p:cNvSpPr txBox="1"/>
           <p:nvPr/>
         </p:nvSpPr>
@@ -2286,7 +2286,7 @@
       </p:sp>
       <p:sp>
         <p:nvSpPr>
-          <p:cNvPr id="12" name="element_136uc5y"/>
+          <p:cNvPr id="12" name="element_6d0bbd1eb433fb6fb13804987f4defac"/>
           <p:cNvSpPr txBox="1"/>
           <p:nvPr/>
         </p:nvSpPr>
@@ -2362,7 +2362,7 @@
       </p:grpSpPr>
       <p:sp>
         <p:nvSpPr>
-          <p:cNvPr id="2" name="element_1ponpq9"/>
+          <p:cNvPr id="2" name="element_bec4971c774830d322c8800996c91d15"/>
           <p:cNvSpPr/>
           <p:nvPr/>
         </p:nvSpPr>
@@ -2389,7 +2389,7 @@
       </p:sp>
       <p:sp>
         <p:nvSpPr>
-          <p:cNvPr id="3" name="element_1mrsm9n"/>
+          <p:cNvPr id="3" name="element_9c7d118eeb0028bb5880c62920e5a089"/>
           <p:cNvSpPr txBox="1"/>
           <p:nvPr/>
         </p:nvSpPr>
@@ -2433,7 +2433,7 @@
       </p:sp>
       <p:sp>
         <p:nvSpPr>
-          <p:cNvPr id="4" name="element_19j4az8"/>
+          <p:cNvPr id="4" name="element_d2e261320b23e4ddf307ef0fb53488d4"/>
           <p:cNvSpPr txBox="1"/>
           <p:nvPr/>
         </p:nvSpPr>
@@ -2477,7 +2477,7 @@
       </p:sp>
       <p:sp>
         <p:nvSpPr>
-          <p:cNvPr id="5" name="element_1oyh9o8"/>
+          <p:cNvPr id="5" name="element_da270d84c46dd7c5bce42ba37f577254"/>
           <p:cNvSpPr txBox="1"/>
           <p:nvPr/>
         </p:nvSpPr>
@@ -2521,7 +2521,7 @@
       </p:sp>
       <p:sp>
         <p:nvSpPr>
-          <p:cNvPr id="6" name="element_194d7xa"/>
+          <p:cNvPr id="6" name="element_06d60c7fbdfbe103ea70639b3db92a7d"/>
           <p:cNvSpPr txBox="1"/>
           <p:nvPr/>
         </p:nvSpPr>
@@ -2565,7 +2565,7 @@
       </p:sp>
       <p:sp>
         <p:nvSpPr>
-          <p:cNvPr id="7" name="element_18udm8b"/>
+          <p:cNvPr id="7" name="element_c7aa8c8046d17a311528f21e2b95e36e"/>
           <p:cNvSpPr txBox="1"/>
           <p:nvPr/>
         </p:nvSpPr>
@@ -2609,7 +2609,7 @@
       </p:sp>
       <p:sp>
         <p:nvSpPr>
-          <p:cNvPr id="8" name="element_18ke0jc"/>
+          <p:cNvPr id="8" name="element_0b696b9755f7429a38de3545757aba7c"/>
           <p:cNvSpPr txBox="1"/>
           <p:nvPr/>
         </p:nvSpPr>
@@ -2653,7 +2653,7 @@
       </p:sp>
       <p:sp>
         <p:nvSpPr>
-          <p:cNvPr id="9" name="element_09ndggn"/>
+          <p:cNvPr id="9" name="element_31f1755c6c5321dfbda16c9e3b588f14"/>
           <p:cNvSpPr txBox="1"/>
           <p:nvPr/>
         </p:nvSpPr>
@@ -2697,7 +2697,7 @@
       </p:sp>
       <p:sp>
         <p:nvSpPr>
-          <p:cNvPr id="10" name="element_1235d23"/>
+          <p:cNvPr id="10" name="element_53f040e31851467ba9d854f51138633f"/>
           <p:cNvSpPr txBox="1"/>
           <p:nvPr/>
         </p:nvSpPr>
@@ -2773,7 +2773,7 @@
       </p:grpSpPr>
       <p:sp>
         <p:nvSpPr>
-          <p:cNvPr id="2" name="element_1wubebu"/>
+          <p:cNvPr id="2" name="element_f6b8788565cb251e9f900665cce2b24a"/>
           <p:cNvSpPr/>
           <p:nvPr/>
         </p:nvSpPr>
@@ -2800,7 +2800,7 @@
       </p:sp>
       <p:sp>
         <p:nvSpPr>
-          <p:cNvPr id="3" name="element_06xhkpo"/>
+          <p:cNvPr id="3" name="element_9351049bb3f96171b9309cba42e89e07"/>
           <p:cNvSpPr txBox="1"/>
           <p:nvPr/>
         </p:nvSpPr>
@@ -2844,7 +2844,7 @@
       </p:sp>
       <p:sp>
         <p:nvSpPr>
-          <p:cNvPr id="4" name="element_12a6eyh"/>
+          <p:cNvPr id="4" name="element_a6b90c2ad4ed46223d3e0bc6a6566578"/>
           <p:cNvSpPr txBox="1"/>
           <p:nvPr/>
         </p:nvSpPr>
@@ -2888,7 +2888,7 @@
       </p:sp>
       <p:sp>
         <p:nvSpPr>
-          <p:cNvPr id="5" name="element_1thd5qd"/>
+          <p:cNvPr id="5" name="element_506193c9ec6a6c785a9803ff99dba72e"/>
           <p:cNvSpPr txBox="1"/>
           <p:nvPr/>
         </p:nvSpPr>
@@ -2932,7 +2932,7 @@
       </p:sp>
       <p:sp>
         <p:nvSpPr>
-          <p:cNvPr id="6" name="element_1cu2e87"/>
+          <p:cNvPr id="6" name="element_cba11e0475d3187ee26d88aaab74e101"/>
           <p:cNvSpPr txBox="1"/>
           <p:nvPr/>
         </p:nvSpPr>
@@ -2976,7 +2976,7 @@
       </p:sp>
       <p:sp>
         <p:nvSpPr>
-          <p:cNvPr id="7" name="element_1d41zx6"/>
+          <p:cNvPr id="7" name="element_5b4ec81acec3013b22296cb1b010c360"/>
           <p:cNvSpPr txBox="1"/>
           <p:nvPr/>
         </p:nvSpPr>
@@ -3020,7 +3020,7 @@
       </p:sp>
       <p:sp>
         <p:nvSpPr>
-          <p:cNvPr id="8" name="element_1de1lm5"/>
+          <p:cNvPr id="8" name="element_c001fe50024c88556ea59c3353469d9e"/>
           <p:cNvSpPr txBox="1"/>
           <p:nvPr/>
         </p:nvSpPr>
@@ -3064,7 +3064,7 @@
       </p:sp>
       <p:sp>
         <p:nvSpPr>
-          <p:cNvPr id="9" name="element_1ir3uw2"/>
+          <p:cNvPr id="9" name="element_18c625c59a81b8210af639abfc6c22ef"/>
           <p:cNvSpPr txBox="1"/>
           <p:nvPr/>
         </p:nvSpPr>
@@ -3108,7 +3108,7 @@
       </p:sp>
       <p:sp>
         <p:nvSpPr>
-          <p:cNvPr id="10" name="element_0yess9o"/>
+          <p:cNvPr id="10" name="element_5568eb63bd88d552e2bb065bfadc4332"/>
           <p:cNvSpPr txBox="1"/>
           <p:nvPr/>
         </p:nvSpPr>
@@ -3184,7 +3184,7 @@
       </p:grpSpPr>
       <p:sp>
         <p:nvSpPr>
-          <p:cNvPr id="2" name="element_0nwkuyj"/>
+          <p:cNvPr id="2" name="element_451bceb6b76b18cbbaf54ad5c83f3d61"/>
           <p:cNvSpPr/>
           <p:nvPr/>
         </p:nvSpPr>
@@ -3211,7 +3211,7 @@
       </p:sp>
       <p:sp>
         <p:nvSpPr>
-          <p:cNvPr id="3" name="element_15u2ojh"/>
+          <p:cNvPr id="3" name="element_99dde8cdfacad0ef4ac0fc63503dbc3a"/>
           <p:cNvSpPr txBox="1"/>
           <p:nvPr/>
         </p:nvSpPr>
@@ -3255,7 +3255,7 @@
       </p:sp>
       <p:sp>
         <p:nvSpPr>
-          <p:cNvPr id="4" name="element_16q181a"/>
+          <p:cNvPr id="4" name="element_ba049b6f37f1e86df6b17725709d980f"/>
           <p:cNvSpPr txBox="1"/>
           <p:nvPr/>
         </p:nvSpPr>
@@ -3299,7 +3299,7 @@
       </p:sp>
       <p:sp>
         <p:nvSpPr>
-          <p:cNvPr id="5" name="element_0emlxnq"/>
+          <p:cNvPr id="5" name="element_9941ba7e56fe225cc28ada1ec419c89a"/>
           <p:cNvSpPr txBox="1"/>
           <p:nvPr/>
         </p:nvSpPr>
@@ -3343,7 +3343,7 @@
       </p:sp>
       <p:sp>
         <p:nvSpPr>
-          <p:cNvPr id="6" name="element_1u1zeiw"/>
+          <p:cNvPr id="6" name="element_6cec29e04e5c73893f580d03152a243c"/>
           <p:cNvSpPr txBox="1"/>
           <p:nvPr/>
         </p:nvSpPr>
@@ -3387,7 +3387,7 @@
       </p:sp>
       <p:sp>
         <p:nvSpPr>
-          <p:cNvPr id="7" name="element_1uvy7lt"/>
+          <p:cNvPr id="7" name="element_ce0b20446094bcd0b863bdffc4dae02e"/>
           <p:cNvSpPr txBox="1"/>
           <p:nvPr/>
         </p:nvSpPr>
@@ -3431,7 +3431,7 @@
       </p:sp>
       <p:sp>
         <p:nvSpPr>
-          <p:cNvPr id="8" name="element_1ulylwu"/>
+          <p:cNvPr id="8" name="element_125aaa95bae681824dc1e50a8a43ac17"/>
           <p:cNvSpPr txBox="1"/>
           <p:nvPr/>
         </p:nvSpPr>
@@ -3475,7 +3475,7 @@
       </p:sp>
       <p:sp>
         <p:nvSpPr>
-          <p:cNvPr id="9" name="element_1oklf46"/>
+          <p:cNvPr id="9" name="element_95f0120403f5e8fe2a139185dd62d031"/>
           <p:cNvSpPr txBox="1"/>
           <p:nvPr/>
         </p:nvSpPr>
@@ -3519,7 +3519,7 @@
       </p:sp>
       <p:sp>
         <p:nvSpPr>
-          <p:cNvPr id="10" name="element_0vfsy8p"/>
+          <p:cNvPr id="10" name="element_966e6fa55884f04f4a7106777cf59f41"/>
           <p:cNvSpPr txBox="1"/>
           <p:nvPr/>
         </p:nvSpPr>
@@ -3563,7 +3563,7 @@
       </p:sp>
       <p:sp>
         <p:nvSpPr>
-          <p:cNvPr id="11" name="element_0iqroet"/>
+          <p:cNvPr id="11" name="element_0977339f5074d3a99ce6fe87af536bcf"/>
           <p:cNvSpPr txBox="1"/>
           <p:nvPr/>
         </p:nvSpPr>
@@ -3607,7 +3607,7 @@
       </p:sp>
       <p:sp>
         <p:nvSpPr>
-          <p:cNvPr id="12" name="element_1sy9z0d"/>
+          <p:cNvPr id="12" name="element_dbf8f3dd75da823a23ca0bd2668e0b2f"/>
           <p:cNvSpPr txBox="1"/>
           <p:nvPr/>
         </p:nvSpPr>
@@ -3683,7 +3683,7 @@
       </p:grpSpPr>
       <p:sp>
         <p:nvSpPr>
-          <p:cNvPr id="2" name="element_0qd9akz"/>
+          <p:cNvPr id="2" name="element_19ca8687bba076db065468bdc6bddfe5"/>
           <p:cNvSpPr/>
           <p:nvPr/>
         </p:nvSpPr>
@@ -3710,7 +3710,7 @@
       </p:sp>
       <p:sp>
         <p:nvSpPr>
-          <p:cNvPr id="3" name="element_0ue0fad"/>
+          <p:cNvPr id="3" name="element_a3663c6d987dd45a61e04186fa690b64"/>
           <p:cNvSpPr txBox="1"/>
           <p:nvPr/>
         </p:nvSpPr>
@@ -3754,7 +3754,7 @@
       </p:sp>
       <p:sp>
         <p:nvSpPr>
-          <p:cNvPr id="4" name="element_18asepi"/>
+          <p:cNvPr id="4" name="element_63f5e0452280dbab46f76ffcc3108a28"/>
           <p:cNvSpPr txBox="1"/>
           <p:nvPr/>
         </p:nvSpPr>
@@ -3798,7 +3798,7 @@
       </p:sp>
       <p:sp>
         <p:nvSpPr>
-          <p:cNvPr id="5" name="element_1o5typa"/>
+          <p:cNvPr id="5" name="element_00a8ec2aa4d636249bf54c358eadea12"/>
           <p:cNvSpPr txBox="1"/>
           <p:nvPr/>
         </p:nvSpPr>
@@ -3842,7 +3842,7 @@
       </p:sp>
       <p:sp>
         <p:nvSpPr>
-          <p:cNvPr id="6" name="element_1b3r18g"/>
+          <p:cNvPr id="6" name="element_fb5592a74423f57b348f285011258b1e"/>
           <p:cNvSpPr txBox="1"/>
           <p:nvPr/>
         </p:nvSpPr>
@@ -3886,7 +3886,7 @@
       </p:sp>
       <p:sp>
         <p:nvSpPr>
-          <p:cNvPr id="7" name="element_1bxpubd"/>
+          <p:cNvPr id="7" name="element_6f765e3d1b1cafb1dd15856bc5f888d4"/>
           <p:cNvSpPr txBox="1"/>
           <p:nvPr/>
         </p:nvSpPr>
@@ -3930,7 +3930,7 @@
       </p:sp>
       <p:sp>
         <p:nvSpPr>
-          <p:cNvPr id="8" name="element_1bnq8me"/>
+          <p:cNvPr id="8" name="element_c1ec97e61c3b3938d801a09e09c29cfc"/>
           <p:cNvSpPr txBox="1"/>
           <p:nvPr/>
         </p:nvSpPr>
@@ -3974,7 +3974,7 @@
       </p:sp>
       <p:sp>
         <p:nvSpPr>
-          <p:cNvPr id="9" name="element_0arzv0d"/>
+          <p:cNvPr id="9" name="element_d1a3255fa93f750afd58a04ff7e48ef5"/>
           <p:cNvSpPr txBox="1"/>
           <p:nvPr/>
         </p:nvSpPr>
@@ -4018,7 +4018,7 @@
       </p:sp>
       <p:sp>
         <p:nvSpPr>
-          <p:cNvPr id="10" name="element_0qilvut"/>
+          <p:cNvPr id="10" name="element_85262c52b8125d6656f63c3f13fb3312"/>
           <p:cNvSpPr txBox="1"/>
           <p:nvPr/>
         </p:nvSpPr>
@@ -4094,7 +4094,7 @@
       </p:grpSpPr>
       <p:sp>
         <p:nvSpPr>
-          <p:cNvPr id="2" name="element_1sm3vsq"/>
+          <p:cNvPr id="2" name="element_ca510e1e6e4d03fa8881b2dd2f24344e"/>
           <p:cNvSpPr/>
           <p:nvPr/>
         </p:nvSpPr>
@@ -4121,7 +4121,7 @@
       </p:sp>
       <p:sp>
         <p:nvSpPr>
-          <p:cNvPr id="3" name="element_0kro0ek"/>
+          <p:cNvPr id="3" name="element_ef302973c8cf89f099df99ee73af225d"/>
           <p:cNvSpPr txBox="1"/>
           <p:nvPr/>
         </p:nvSpPr>
@@ -4165,7 +4165,7 @@
       </p:sp>
       <p:sp>
         <p:nvSpPr>
-          <p:cNvPr id="4" name="element_1w8teh5"/>
+          <p:cNvPr id="4" name="element_13ca8ba036a904ea56d8bca9318afdd3"/>
           <p:cNvSpPr txBox="1"/>
           <p:nvPr/>
         </p:nvSpPr>
@@ -4209,7 +4209,7 @@
       </p:sp>
       <p:sp>
         <p:nvSpPr>
-          <p:cNvPr id="5" name="element_0h6h6lx"/>
+          <p:cNvPr id="5" name="element_d4bce2e3d3c4fc2e222c109f3e3fd619"/>
           <p:cNvSpPr txBox="1"/>
           <p:nvPr/>
         </p:nvSpPr>
@@ -4253,7 +4253,7 @@
       </p:sp>
       <p:sp>
         <p:nvSpPr>
-          <p:cNvPr id="6" name="element_1rb8e5z"/>
+          <p:cNvPr id="6" name="element_d36588f2838c48e996792c40d6c71cd7"/>
           <p:cNvSpPr txBox="1"/>
           <p:nvPr/>
         </p:nvSpPr>
@@ -4297,7 +4297,7 @@
       </p:sp>
       <p:sp>
         <p:nvSpPr>
-          <p:cNvPr id="7" name="element_1rl7zuy"/>
+          <p:cNvPr id="7" name="element_ecc6b3b19966be17f0ae9a960450697b"/>
           <p:cNvSpPr txBox="1"/>
           <p:nvPr/>
         </p:nvSpPr>
@@ -4341,7 +4341,7 @@
       </p:sp>
       <p:sp>
         <p:nvSpPr>
-          <p:cNvPr id="8" name="element_1rv7ljx"/>
+          <p:cNvPr id="8" name="element_7b9ccab240d4d9748a87a580267929e5"/>
           <p:cNvSpPr txBox="1"/>
           <p:nvPr/>
         </p:nvSpPr>
@@ -4385,7 +4385,7 @@
       </p:sp>
       <p:sp>
         <p:nvSpPr>
-          <p:cNvPr id="9" name="element_0nd9zw2"/>
+          <p:cNvPr id="9" name="element_662ef7e94e555044c2f18e59d2f57d0d"/>
           <p:cNvSpPr txBox="1"/>
           <p:nvPr/>
         </p:nvSpPr>
@@ -4429,7 +4429,7 @@
       </p:sp>
       <p:sp>
         <p:nvSpPr>
-          <p:cNvPr id="10" name="element_1qjr9kc"/>
+          <p:cNvPr id="10" name="element_91924c9ea1e07b25e41eb251a77b36f3"/>
           <p:cNvSpPr txBox="1"/>
           <p:nvPr/>
         </p:nvSpPr>

</xml_diff>

<commit_message>
feat(nodeslide): align v3 editor and harden launch flow
</commit_message>
<xml_diff>
--- a/docs/dogfood/nodeslide-domain-v1/nodeslide-golden.pptx
+++ b/docs/dogfood/nodeslide-domain-v1/nodeslide-golden.pptx
@@ -511,7 +511,7 @@
               <a:t>Narrative role: NodeSlide / 01. Keep the spoken transition focused on “Build the story. Keep every decision editable.”
 Evidence note: Content is based on the supplied creation brief. Illustrative examples are not independently verified; replace them with measured evidence before external publication.
 NodeSlide sources
-[source_96a6a42be4bdf0cef8b6f3f8c453dbfb] NodeSlide product brief
+[source_fe3f18f3463dcd91585199a0d62f9eff] NodeSlide product brief
 Citation: Show how NodeSlide turns presentation work into a traceable, editable, reviewable system.
 Disclaimer: Internal working material</a:t>
             </a:r>
@@ -604,10 +604,10 @@
               <a:t>Narrative role: Scenario / 02. Keep the spoken transition focused on “Keep source context attached as the story moves.”
 Evidence note: Content is based on the supplied creation brief. Illustrative examples are not independently verified; replace them with measured evidence before external publication.
 NodeSlide sources
-[source_96a6a42be4bdf0cef8b6f3f8c453dbfb] NodeSlide product brief
+[source_fe3f18f3463dcd91585199a0d62f9eff] NodeSlide product brief
 Citation: Show how NodeSlide turns presentation work into a traceable, editable, reviewable system.
 Disclaimer: Internal working material
-[source_af6acf1aa730a0e091a9f391a61fcd2d] Golden workflow scenario
+[source_cdf31d0bdc30c453c8c14d285e0f87bf] Golden workflow scenario
 Citation: Qualitative product-workflow scenario for demonstrating NodeSlide; no measured customer benchmark is claimed.
 Disclaimer: Internal working material</a:t>
             </a:r>
@@ -700,7 +700,7 @@
               <a:t>Narrative role: Foundation / 03. Keep the spoken transition focused on “Structure turns a visual artifact into an operating surface.”
 Evidence note: Content is based on the supplied creation brief. Illustrative examples are not independently verified; replace them with measured evidence before external publication.
 NodeSlide sources
-[source_96a6a42be4bdf0cef8b6f3f8c453dbfb] NodeSlide product brief
+[source_fe3f18f3463dcd91585199a0d62f9eff] NodeSlide product brief
 Citation: Show how NodeSlide turns presentation work into a traceable, editable, reviewable system.
 Disclaimer: Internal working material</a:t>
             </a:r>
@@ -793,7 +793,7 @@
               <a:t>Narrative role: Workflow / 04. Keep the spoken transition focused on “Plan → propose → commit, with scope checked at every boundary.”
 Evidence note: Content is based on the supplied creation brief. Illustrative examples are not independently verified; replace them with measured evidence before external publication.
 NodeSlide sources
-[source_96a6a42be4bdf0cef8b6f3f8c453dbfb] NodeSlide product brief
+[source_fe3f18f3463dcd91585199a0d62f9eff] NodeSlide product brief
 Citation: Show how NodeSlide turns presentation work into a traceable, editable, reviewable system.
 Disclaimer: Internal working material</a:t>
             </a:r>
@@ -886,10 +886,10 @@
               <a:t>Narrative role: Proof / 05. Keep the spoken transition focused on “A beautiful deck still needs deterministic gates.”
 Evidence note: Content is based on the supplied creation brief. Illustrative examples are not independently verified; replace them with measured evidence before external publication.
 NodeSlide sources
-[source_96a6a42be4bdf0cef8b6f3f8c453dbfb] NodeSlide product brief
+[source_fe3f18f3463dcd91585199a0d62f9eff] NodeSlide product brief
 Citation: Show how NodeSlide turns presentation work into a traceable, editable, reviewable system.
 Disclaimer: Internal working material
-[source_af6acf1aa730a0e091a9f391a61fcd2d] Golden workflow scenario
+[source_cdf31d0bdc30c453c8c14d285e0f87bf] Golden workflow scenario
 Citation: Qualitative product-workflow scenario for demonstrating NodeSlide; no measured customer benchmark is claimed.
 Disclaimer: Internal working material</a:t>
             </a:r>
@@ -982,7 +982,7 @@
               <a:t>Narrative role: Trust / 06. Keep the spoken transition focused on “Comments become context. Patches remain choices.”
 Evidence note: Content is based on the supplied creation brief. Illustrative examples are not independently verified; replace them with measured evidence before external publication.
 NodeSlide sources
-[source_96a6a42be4bdf0cef8b6f3f8c453dbfb] NodeSlide product brief
+[source_fe3f18f3463dcd91585199a0d62f9eff] NodeSlide product brief
 Citation: Show how NodeSlide turns presentation work into a traceable, editable, reviewable system.
 Disclaimer: Internal working material</a:t>
             </a:r>
@@ -1075,7 +1075,7 @@
               <a:t>Narrative role: Next / 07. Keep the spoken transition focused on “Move at presentation speed without giving up engineering-grade trust.”
 Evidence note: Content is based on the supplied creation brief. Illustrative examples are not independently verified; replace them with measured evidence before external publication.
 NodeSlide sources
-[source_96a6a42be4bdf0cef8b6f3f8c453dbfb] NodeSlide product brief
+[source_fe3f18f3463dcd91585199a0d62f9eff] NodeSlide product brief
 Citation: Show how NodeSlide turns presentation work into a traceable, editable, reviewable system.
 Disclaimer: Internal working material</a:t>
             </a:r>
@@ -1452,7 +1452,7 @@
       </p:grpSpPr>
       <p:sp>
         <p:nvSpPr>
-          <p:cNvPr id="2" name="element_370ba551ddbd0662d7fc04acd744609e"/>
+          <p:cNvPr id="2" name="element_53b47f7716ac7ee776b60dc98b6c44a3"/>
           <p:cNvSpPr/>
           <p:nvPr/>
         </p:nvSpPr>
@@ -1479,7 +1479,7 @@
       </p:sp>
       <p:sp>
         <p:nvSpPr>
-          <p:cNvPr id="3" name="element_2a17a5661c042a04a73ecdc0813e2cdb"/>
+          <p:cNvPr id="3" name="element_66e80d5e2b81ef916f8835f547d706d3"/>
           <p:cNvSpPr txBox="1"/>
           <p:nvPr/>
         </p:nvSpPr>
@@ -1523,7 +1523,7 @@
       </p:sp>
       <p:sp>
         <p:nvSpPr>
-          <p:cNvPr id="4" name="element_61ee0f53c258556cd84cfd7bac8aae3a"/>
+          <p:cNvPr id="4" name="element_349c18e5b264cb65bae0730d88074d1c"/>
           <p:cNvSpPr txBox="1"/>
           <p:nvPr/>
         </p:nvSpPr>
@@ -1567,7 +1567,7 @@
       </p:sp>
       <p:sp>
         <p:nvSpPr>
-          <p:cNvPr id="5" name="element_889fb4fc4d96b7c0851e9fcfd46a6bdc"/>
+          <p:cNvPr id="5" name="element_f7c0240db9c7ebd58b411e85a657754f"/>
           <p:cNvSpPr txBox="1"/>
           <p:nvPr/>
         </p:nvSpPr>
@@ -1611,7 +1611,7 @@
       </p:sp>
       <p:sp>
         <p:nvSpPr>
-          <p:cNvPr id="6" name="element_640b14d5f6930f912de30905268178b8"/>
+          <p:cNvPr id="6" name="element_d1bdecc8294567284b5905502c7a7c41"/>
           <p:cNvSpPr txBox="1"/>
           <p:nvPr/>
         </p:nvSpPr>
@@ -1655,7 +1655,7 @@
       </p:sp>
       <p:sp>
         <p:nvSpPr>
-          <p:cNvPr id="7" name="element_c26b53ad82326babcb864b1713b5a8f0"/>
+          <p:cNvPr id="7" name="element_2e4f2c69c89f5d8b8e430a46fb18de26"/>
           <p:cNvSpPr txBox="1"/>
           <p:nvPr/>
         </p:nvSpPr>
@@ -1699,7 +1699,7 @@
       </p:sp>
       <p:sp>
         <p:nvSpPr>
-          <p:cNvPr id="8" name="element_8ea417e51d2186a7e95e517038fc0b91"/>
+          <p:cNvPr id="8" name="element_71a52c1059eb45d6c2cdf88dc6fc4857"/>
           <p:cNvSpPr txBox="1"/>
           <p:nvPr/>
         </p:nvSpPr>
@@ -1743,7 +1743,7 @@
       </p:sp>
       <p:sp>
         <p:nvSpPr>
-          <p:cNvPr id="9" name="element_a3e163e2e0e15fdee5f2c6cabeec87c5"/>
+          <p:cNvPr id="9" name="element_9aa0ef692abcc00b9331a3ead8fe1f7b"/>
           <p:cNvSpPr txBox="1"/>
           <p:nvPr/>
         </p:nvSpPr>
@@ -1787,7 +1787,7 @@
       </p:sp>
       <p:sp>
         <p:nvSpPr>
-          <p:cNvPr id="10" name="element_9f8bf6a787f0475c7a366fd188ce022e"/>
+          <p:cNvPr id="10" name="element_d4b8594043f56a9be200a1b811f8d83d"/>
           <p:cNvSpPr txBox="1"/>
           <p:nvPr/>
         </p:nvSpPr>
@@ -1863,7 +1863,7 @@
       </p:grpSpPr>
       <p:sp>
         <p:nvSpPr>
-          <p:cNvPr id="2" name="element_0323b6c8041a56d2e1a0f15fa191f2d0"/>
+          <p:cNvPr id="2" name="element_cbcc8de14cb7481c51229c1af336a05f"/>
           <p:cNvSpPr/>
           <p:nvPr/>
         </p:nvSpPr>
@@ -1890,7 +1890,7 @@
       </p:sp>
       <p:sp>
         <p:nvSpPr>
-          <p:cNvPr id="3" name="element_4b4d1dc69245682e345b15e626972fd9"/>
+          <p:cNvPr id="3" name="element_832b2226326dc765766ed6882c405f61"/>
           <p:cNvSpPr txBox="1"/>
           <p:nvPr/>
         </p:nvSpPr>
@@ -1934,7 +1934,7 @@
       </p:sp>
       <p:sp>
         <p:nvSpPr>
-          <p:cNvPr id="4" name="element_789778442a6ae438cd0ecb197d98edaf"/>
+          <p:cNvPr id="4" name="element_2a053b0990de5a774a4dba0578cda7da"/>
           <p:cNvSpPr txBox="1"/>
           <p:nvPr/>
         </p:nvSpPr>
@@ -1978,7 +1978,7 @@
       </p:sp>
       <p:sp>
         <p:nvSpPr>
-          <p:cNvPr id="5" name="element_f995c27b8b789b00520e356587acd4f5"/>
+          <p:cNvPr id="5" name="element_40334008af738053147f12e7af8f088c"/>
           <p:cNvSpPr txBox="1"/>
           <p:nvPr/>
         </p:nvSpPr>
@@ -2022,7 +2022,7 @@
       </p:sp>
       <p:sp>
         <p:nvSpPr>
-          <p:cNvPr id="6" name="element_ec3dd98375c7ad4afedf99c4c93224c9"/>
+          <p:cNvPr id="6" name="element_4e167ccdb490292c7b0fba15a315ecef"/>
           <p:cNvSpPr txBox="1"/>
           <p:nvPr/>
         </p:nvSpPr>
@@ -2066,7 +2066,7 @@
       </p:sp>
       <p:sp>
         <p:nvSpPr>
-          <p:cNvPr id="7" name="element_d78f82eb60b33b82068b8455e74a04e7"/>
+          <p:cNvPr id="7" name="element_bd69d5283543b3fb21ae6483a302d4d7"/>
           <p:cNvSpPr txBox="1"/>
           <p:nvPr/>
         </p:nvSpPr>
@@ -2110,7 +2110,7 @@
       </p:sp>
       <p:sp>
         <p:nvSpPr>
-          <p:cNvPr id="8" name="element_a7d2620b40de0c871dfe92184d50a0da"/>
+          <p:cNvPr id="8" name="element_c7fbd294d269b565c5f2bcae80df495b"/>
           <p:cNvSpPr txBox="1"/>
           <p:nvPr/>
         </p:nvSpPr>
@@ -2154,7 +2154,7 @@
       </p:sp>
       <p:sp>
         <p:nvSpPr>
-          <p:cNvPr id="9" name="element_bec6c837aaac7a129e0d827ac1c37b61"/>
+          <p:cNvPr id="9" name="element_4d99e843358969f04da70874256da0b1"/>
           <p:cNvSpPr txBox="1"/>
           <p:nvPr/>
         </p:nvSpPr>
@@ -2198,7 +2198,7 @@
       </p:sp>
       <p:sp>
         <p:nvSpPr>
-          <p:cNvPr id="10" name="element_58305a50bc1379606692fa40c8a074f7"/>
+          <p:cNvPr id="10" name="element_225bc32d00a91bbe4b5d246eb1aa26d1"/>
           <p:cNvSpPr txBox="1"/>
           <p:nvPr/>
         </p:nvSpPr>
@@ -2242,7 +2242,7 @@
       </p:sp>
       <p:sp>
         <p:nvSpPr>
-          <p:cNvPr id="11" name="element_49bbb381be7ee11d3d18ed0dc590f285"/>
+          <p:cNvPr id="11" name="element_c13faa5abad08aecc5282aed3dc1f672"/>
           <p:cNvSpPr txBox="1"/>
           <p:nvPr/>
         </p:nvSpPr>
@@ -2286,7 +2286,7 @@
       </p:sp>
       <p:sp>
         <p:nvSpPr>
-          <p:cNvPr id="12" name="element_6d0bbd1eb433fb6fb13804987f4defac"/>
+          <p:cNvPr id="12" name="element_7d3cbd704f6c42e0ec9efe2f5cb50a8a"/>
           <p:cNvSpPr txBox="1"/>
           <p:nvPr/>
         </p:nvSpPr>
@@ -2362,7 +2362,7 @@
       </p:grpSpPr>
       <p:sp>
         <p:nvSpPr>
-          <p:cNvPr id="2" name="element_bec4971c774830d322c8800996c91d15"/>
+          <p:cNvPr id="2" name="element_3647a6b20b587bdbb12ae59305dee26b"/>
           <p:cNvSpPr/>
           <p:nvPr/>
         </p:nvSpPr>
@@ -2389,7 +2389,7 @@
       </p:sp>
       <p:sp>
         <p:nvSpPr>
-          <p:cNvPr id="3" name="element_9c7d118eeb0028bb5880c62920e5a089"/>
+          <p:cNvPr id="3" name="element_43fd065848fe8d854b5a4ae14bcf6686"/>
           <p:cNvSpPr txBox="1"/>
           <p:nvPr/>
         </p:nvSpPr>
@@ -2433,7 +2433,7 @@
       </p:sp>
       <p:sp>
         <p:nvSpPr>
-          <p:cNvPr id="4" name="element_d2e261320b23e4ddf307ef0fb53488d4"/>
+          <p:cNvPr id="4" name="element_6d402bdba9ed12a19bd42efc3fc9bd1e"/>
           <p:cNvSpPr txBox="1"/>
           <p:nvPr/>
         </p:nvSpPr>
@@ -2477,7 +2477,7 @@
       </p:sp>
       <p:sp>
         <p:nvSpPr>
-          <p:cNvPr id="5" name="element_da270d84c46dd7c5bce42ba37f577254"/>
+          <p:cNvPr id="5" name="element_db2264064c280e50d2eb7751d12ad471"/>
           <p:cNvSpPr txBox="1"/>
           <p:nvPr/>
         </p:nvSpPr>
@@ -2521,7 +2521,7 @@
       </p:sp>
       <p:sp>
         <p:nvSpPr>
-          <p:cNvPr id="6" name="element_06d60c7fbdfbe103ea70639b3db92a7d"/>
+          <p:cNvPr id="6" name="element_2a2624b7e1e658b405bc07bb10b5cee3"/>
           <p:cNvSpPr txBox="1"/>
           <p:nvPr/>
         </p:nvSpPr>
@@ -2565,7 +2565,7 @@
       </p:sp>
       <p:sp>
         <p:nvSpPr>
-          <p:cNvPr id="7" name="element_c7aa8c8046d17a311528f21e2b95e36e"/>
+          <p:cNvPr id="7" name="element_bd7374a44f1ec979fdd8f069c158da7c"/>
           <p:cNvSpPr txBox="1"/>
           <p:nvPr/>
         </p:nvSpPr>
@@ -2609,7 +2609,7 @@
       </p:sp>
       <p:sp>
         <p:nvSpPr>
-          <p:cNvPr id="8" name="element_0b696b9755f7429a38de3545757aba7c"/>
+          <p:cNvPr id="8" name="element_0d534e0069da27efafdd1bf9b5430ca4"/>
           <p:cNvSpPr txBox="1"/>
           <p:nvPr/>
         </p:nvSpPr>
@@ -2653,7 +2653,7 @@
       </p:sp>
       <p:sp>
         <p:nvSpPr>
-          <p:cNvPr id="9" name="element_31f1755c6c5321dfbda16c9e3b588f14"/>
+          <p:cNvPr id="9" name="element_fc8710ce90ca0f1dec56695b94ce2d21"/>
           <p:cNvSpPr txBox="1"/>
           <p:nvPr/>
         </p:nvSpPr>
@@ -2697,7 +2697,7 @@
       </p:sp>
       <p:sp>
         <p:nvSpPr>
-          <p:cNvPr id="10" name="element_53f040e31851467ba9d854f51138633f"/>
+          <p:cNvPr id="10" name="element_ba0cb98647b302edc5c2fb15794534d7"/>
           <p:cNvSpPr txBox="1"/>
           <p:nvPr/>
         </p:nvSpPr>
@@ -2773,7 +2773,7 @@
       </p:grpSpPr>
       <p:sp>
         <p:nvSpPr>
-          <p:cNvPr id="2" name="element_f6b8788565cb251e9f900665cce2b24a"/>
+          <p:cNvPr id="2" name="element_1c1be18343a0f638d3b0588a8b7f3124"/>
           <p:cNvSpPr/>
           <p:nvPr/>
         </p:nvSpPr>
@@ -2800,7 +2800,7 @@
       </p:sp>
       <p:sp>
         <p:nvSpPr>
-          <p:cNvPr id="3" name="element_9351049bb3f96171b9309cba42e89e07"/>
+          <p:cNvPr id="3" name="element_40f2507663d2717ac27a77f51bb1e5e4"/>
           <p:cNvSpPr txBox="1"/>
           <p:nvPr/>
         </p:nvSpPr>
@@ -2844,7 +2844,7 @@
       </p:sp>
       <p:sp>
         <p:nvSpPr>
-          <p:cNvPr id="4" name="element_a6b90c2ad4ed46223d3e0bc6a6566578"/>
+          <p:cNvPr id="4" name="element_66ff8fc9034013e53d12d31b8131840a"/>
           <p:cNvSpPr txBox="1"/>
           <p:nvPr/>
         </p:nvSpPr>
@@ -2888,7 +2888,7 @@
       </p:sp>
       <p:sp>
         <p:nvSpPr>
-          <p:cNvPr id="5" name="element_506193c9ec6a6c785a9803ff99dba72e"/>
+          <p:cNvPr id="5" name="element_e9be460b5c4f49085481a78efbc0c0f7"/>
           <p:cNvSpPr txBox="1"/>
           <p:nvPr/>
         </p:nvSpPr>
@@ -2932,7 +2932,7 @@
       </p:sp>
       <p:sp>
         <p:nvSpPr>
-          <p:cNvPr id="6" name="element_cba11e0475d3187ee26d88aaab74e101"/>
+          <p:cNvPr id="6" name="element_ad3ecacdd1c141637eb417fc6746a1ee"/>
           <p:cNvSpPr txBox="1"/>
           <p:nvPr/>
         </p:nvSpPr>
@@ -2976,7 +2976,7 @@
       </p:sp>
       <p:sp>
         <p:nvSpPr>
-          <p:cNvPr id="7" name="element_5b4ec81acec3013b22296cb1b010c360"/>
+          <p:cNvPr id="7" name="element_f403681ef0f5833b7d0b7f6b55baf02f"/>
           <p:cNvSpPr txBox="1"/>
           <p:nvPr/>
         </p:nvSpPr>
@@ -3020,7 +3020,7 @@
       </p:sp>
       <p:sp>
         <p:nvSpPr>
-          <p:cNvPr id="8" name="element_c001fe50024c88556ea59c3353469d9e"/>
+          <p:cNvPr id="8" name="element_3301b22f6dfdd33fb4d9a7f1ee4379b9"/>
           <p:cNvSpPr txBox="1"/>
           <p:nvPr/>
         </p:nvSpPr>
@@ -3064,7 +3064,7 @@
       </p:sp>
       <p:sp>
         <p:nvSpPr>
-          <p:cNvPr id="9" name="element_18c625c59a81b8210af639abfc6c22ef"/>
+          <p:cNvPr id="9" name="element_19bf74ea977cba1d6ea974e5b0561610"/>
           <p:cNvSpPr txBox="1"/>
           <p:nvPr/>
         </p:nvSpPr>
@@ -3108,7 +3108,7 @@
       </p:sp>
       <p:sp>
         <p:nvSpPr>
-          <p:cNvPr id="10" name="element_5568eb63bd88d552e2bb065bfadc4332"/>
+          <p:cNvPr id="10" name="element_2227e14e2c08b3d20ba1b2416440d3fc"/>
           <p:cNvSpPr txBox="1"/>
           <p:nvPr/>
         </p:nvSpPr>
@@ -3184,7 +3184,7 @@
       </p:grpSpPr>
       <p:sp>
         <p:nvSpPr>
-          <p:cNvPr id="2" name="element_451bceb6b76b18cbbaf54ad5c83f3d61"/>
+          <p:cNvPr id="2" name="element_6c59da1c9425b8d2937c8a23fa4538f9"/>
           <p:cNvSpPr/>
           <p:nvPr/>
         </p:nvSpPr>
@@ -3211,7 +3211,7 @@
       </p:sp>
       <p:sp>
         <p:nvSpPr>
-          <p:cNvPr id="3" name="element_99dde8cdfacad0ef4ac0fc63503dbc3a"/>
+          <p:cNvPr id="3" name="element_f062dabc9bf1deb419aff68f46ea022c"/>
           <p:cNvSpPr txBox="1"/>
           <p:nvPr/>
         </p:nvSpPr>
@@ -3255,7 +3255,7 @@
       </p:sp>
       <p:sp>
         <p:nvSpPr>
-          <p:cNvPr id="4" name="element_ba049b6f37f1e86df6b17725709d980f"/>
+          <p:cNvPr id="4" name="element_9cf22a76d2c6486c863f73f6a59a1225"/>
           <p:cNvSpPr txBox="1"/>
           <p:nvPr/>
         </p:nvSpPr>
@@ -3299,7 +3299,7 @@
       </p:sp>
       <p:sp>
         <p:nvSpPr>
-          <p:cNvPr id="5" name="element_9941ba7e56fe225cc28ada1ec419c89a"/>
+          <p:cNvPr id="5" name="element_c3c93b3900b0ab2846fac09c8068db23"/>
           <p:cNvSpPr txBox="1"/>
           <p:nvPr/>
         </p:nvSpPr>
@@ -3343,7 +3343,7 @@
       </p:sp>
       <p:sp>
         <p:nvSpPr>
-          <p:cNvPr id="6" name="element_6cec29e04e5c73893f580d03152a243c"/>
+          <p:cNvPr id="6" name="element_c6fdf159c7579e5e5e34bde7db2af42c"/>
           <p:cNvSpPr txBox="1"/>
           <p:nvPr/>
         </p:nvSpPr>
@@ -3387,7 +3387,7 @@
       </p:sp>
       <p:sp>
         <p:nvSpPr>
-          <p:cNvPr id="7" name="element_ce0b20446094bcd0b863bdffc4dae02e"/>
+          <p:cNvPr id="7" name="element_2767722c982282015c119479cc633ca0"/>
           <p:cNvSpPr txBox="1"/>
           <p:nvPr/>
         </p:nvSpPr>
@@ -3431,7 +3431,7 @@
       </p:sp>
       <p:sp>
         <p:nvSpPr>
-          <p:cNvPr id="8" name="element_125aaa95bae681824dc1e50a8a43ac17"/>
+          <p:cNvPr id="8" name="element_ae9fff346f77b8b6b4eb92152c9dce10"/>
           <p:cNvSpPr txBox="1"/>
           <p:nvPr/>
         </p:nvSpPr>
@@ -3475,7 +3475,7 @@
       </p:sp>
       <p:sp>
         <p:nvSpPr>
-          <p:cNvPr id="9" name="element_95f0120403f5e8fe2a139185dd62d031"/>
+          <p:cNvPr id="9" name="element_718abc118afcc1683aad02b5bb2e4ed8"/>
           <p:cNvSpPr txBox="1"/>
           <p:nvPr/>
         </p:nvSpPr>
@@ -3519,7 +3519,7 @@
       </p:sp>
       <p:sp>
         <p:nvSpPr>
-          <p:cNvPr id="10" name="element_966e6fa55884f04f4a7106777cf59f41"/>
+          <p:cNvPr id="10" name="element_9dae0dd68d5ea9b727b2144d18dc0224"/>
           <p:cNvSpPr txBox="1"/>
           <p:nvPr/>
         </p:nvSpPr>
@@ -3563,7 +3563,7 @@
       </p:sp>
       <p:sp>
         <p:nvSpPr>
-          <p:cNvPr id="11" name="element_0977339f5074d3a99ce6fe87af536bcf"/>
+          <p:cNvPr id="11" name="element_34b89ff3bb1701c41cd6ed807d1b96a0"/>
           <p:cNvSpPr txBox="1"/>
           <p:nvPr/>
         </p:nvSpPr>
@@ -3607,7 +3607,7 @@
       </p:sp>
       <p:sp>
         <p:nvSpPr>
-          <p:cNvPr id="12" name="element_dbf8f3dd75da823a23ca0bd2668e0b2f"/>
+          <p:cNvPr id="12" name="element_a3a8636f20b8117af7d3e4ce6bb9ba45"/>
           <p:cNvSpPr txBox="1"/>
           <p:nvPr/>
         </p:nvSpPr>
@@ -3683,7 +3683,7 @@
       </p:grpSpPr>
       <p:sp>
         <p:nvSpPr>
-          <p:cNvPr id="2" name="element_19ca8687bba076db065468bdc6bddfe5"/>
+          <p:cNvPr id="2" name="element_800b2f113b338f30bd9a870c07d15a37"/>
           <p:cNvSpPr/>
           <p:nvPr/>
         </p:nvSpPr>
@@ -3710,7 +3710,7 @@
       </p:sp>
       <p:sp>
         <p:nvSpPr>
-          <p:cNvPr id="3" name="element_a3663c6d987dd45a61e04186fa690b64"/>
+          <p:cNvPr id="3" name="element_830eef9a4f57f16c5d1409477dbc2e92"/>
           <p:cNvSpPr txBox="1"/>
           <p:nvPr/>
         </p:nvSpPr>
@@ -3754,7 +3754,7 @@
       </p:sp>
       <p:sp>
         <p:nvSpPr>
-          <p:cNvPr id="4" name="element_63f5e0452280dbab46f76ffcc3108a28"/>
+          <p:cNvPr id="4" name="element_c48d6a65b2b68554164e634a802ded7d"/>
           <p:cNvSpPr txBox="1"/>
           <p:nvPr/>
         </p:nvSpPr>
@@ -3798,7 +3798,7 @@
       </p:sp>
       <p:sp>
         <p:nvSpPr>
-          <p:cNvPr id="5" name="element_00a8ec2aa4d636249bf54c358eadea12"/>
+          <p:cNvPr id="5" name="element_d98dd9d286f1364587c5d1525b9b723f"/>
           <p:cNvSpPr txBox="1"/>
           <p:nvPr/>
         </p:nvSpPr>
@@ -3842,7 +3842,7 @@
       </p:sp>
       <p:sp>
         <p:nvSpPr>
-          <p:cNvPr id="6" name="element_fb5592a74423f57b348f285011258b1e"/>
+          <p:cNvPr id="6" name="element_a6f5c447aa37ce6e76fe83cd0dc87938"/>
           <p:cNvSpPr txBox="1"/>
           <p:nvPr/>
         </p:nvSpPr>
@@ -3886,7 +3886,7 @@
       </p:sp>
       <p:sp>
         <p:nvSpPr>
-          <p:cNvPr id="7" name="element_6f765e3d1b1cafb1dd15856bc5f888d4"/>
+          <p:cNvPr id="7" name="element_344edf4cc83f40fe76c1cc569ba4ed9e"/>
           <p:cNvSpPr txBox="1"/>
           <p:nvPr/>
         </p:nvSpPr>
@@ -3930,7 +3930,7 @@
       </p:sp>
       <p:sp>
         <p:nvSpPr>
-          <p:cNvPr id="8" name="element_c1ec97e61c3b3938d801a09e09c29cfc"/>
+          <p:cNvPr id="8" name="element_f2e23a39e10c391a91aa50c8b927e6a8"/>
           <p:cNvSpPr txBox="1"/>
           <p:nvPr/>
         </p:nvSpPr>
@@ -3974,7 +3974,7 @@
       </p:sp>
       <p:sp>
         <p:nvSpPr>
-          <p:cNvPr id="9" name="element_d1a3255fa93f750afd58a04ff7e48ef5"/>
+          <p:cNvPr id="9" name="element_9a8b030e5eae68f982a55a608969958f"/>
           <p:cNvSpPr txBox="1"/>
           <p:nvPr/>
         </p:nvSpPr>
@@ -4018,7 +4018,7 @@
       </p:sp>
       <p:sp>
         <p:nvSpPr>
-          <p:cNvPr id="10" name="element_85262c52b8125d6656f63c3f13fb3312"/>
+          <p:cNvPr id="10" name="element_7c2513557ea4b3f3c2d7b0089460b10e"/>
           <p:cNvSpPr txBox="1"/>
           <p:nvPr/>
         </p:nvSpPr>
@@ -4094,7 +4094,7 @@
       </p:grpSpPr>
       <p:sp>
         <p:nvSpPr>
-          <p:cNvPr id="2" name="element_ca510e1e6e4d03fa8881b2dd2f24344e"/>
+          <p:cNvPr id="2" name="element_c94d091cdc3e11e427e266892f4a4017"/>
           <p:cNvSpPr/>
           <p:nvPr/>
         </p:nvSpPr>
@@ -4121,7 +4121,7 @@
       </p:sp>
       <p:sp>
         <p:nvSpPr>
-          <p:cNvPr id="3" name="element_ef302973c8cf89f099df99ee73af225d"/>
+          <p:cNvPr id="3" name="element_7ac643218aa6bd00285c8ac93fa3ca30"/>
           <p:cNvSpPr txBox="1"/>
           <p:nvPr/>
         </p:nvSpPr>
@@ -4165,7 +4165,7 @@
       </p:sp>
       <p:sp>
         <p:nvSpPr>
-          <p:cNvPr id="4" name="element_13ca8ba036a904ea56d8bca9318afdd3"/>
+          <p:cNvPr id="4" name="element_b90864e07e3c485affc98c58f4b40234"/>
           <p:cNvSpPr txBox="1"/>
           <p:nvPr/>
         </p:nvSpPr>
@@ -4209,7 +4209,7 @@
       </p:sp>
       <p:sp>
         <p:nvSpPr>
-          <p:cNvPr id="5" name="element_d4bce2e3d3c4fc2e222c109f3e3fd619"/>
+          <p:cNvPr id="5" name="element_a8e135f63583f24efd8b955ac404e63c"/>
           <p:cNvSpPr txBox="1"/>
           <p:nvPr/>
         </p:nvSpPr>
@@ -4253,7 +4253,7 @@
       </p:sp>
       <p:sp>
         <p:nvSpPr>
-          <p:cNvPr id="6" name="element_d36588f2838c48e996792c40d6c71cd7"/>
+          <p:cNvPr id="6" name="element_68a25cb60e3026ce87be8282cc5c293e"/>
           <p:cNvSpPr txBox="1"/>
           <p:nvPr/>
         </p:nvSpPr>
@@ -4297,7 +4297,7 @@
       </p:sp>
       <p:sp>
         <p:nvSpPr>
-          <p:cNvPr id="7" name="element_ecc6b3b19966be17f0ae9a960450697b"/>
+          <p:cNvPr id="7" name="element_1e31cfa434cc9a946f89b7cc06710c96"/>
           <p:cNvSpPr txBox="1"/>
           <p:nvPr/>
         </p:nvSpPr>
@@ -4341,7 +4341,7 @@
       </p:sp>
       <p:sp>
         <p:nvSpPr>
-          <p:cNvPr id="8" name="element_7b9ccab240d4d9748a87a580267929e5"/>
+          <p:cNvPr id="8" name="element_2889b1f64385cb62dcba74677cf33e2c"/>
           <p:cNvSpPr txBox="1"/>
           <p:nvPr/>
         </p:nvSpPr>
@@ -4385,7 +4385,7 @@
       </p:sp>
       <p:sp>
         <p:nvSpPr>
-          <p:cNvPr id="9" name="element_662ef7e94e555044c2f18e59d2f57d0d"/>
+          <p:cNvPr id="9" name="element_24b34ae693595a9403db115430298cd4"/>
           <p:cNvSpPr txBox="1"/>
           <p:nvPr/>
         </p:nvSpPr>
@@ -4429,7 +4429,7 @@
       </p:sp>
       <p:sp>
         <p:nvSpPr>
-          <p:cNvPr id="10" name="element_91924c9ea1e07b25e41eb251a77b36f3"/>
+          <p:cNvPr id="10" name="element_1e0d799f00077c09182d90dda0d43f00"/>
           <p:cNvSpPr txBox="1"/>
           <p:nvPr/>
         </p:nvSpPr>

</xml_diff>

<commit_message>
feat(nodeslide): ship v3 private-preview editor (#4)
Align the editor with the supplied v3 interface, preserve authoritative patch/receipt semantics, harden first-run and fallback behavior, and add verified responsive/private-preview release evidence.
</commit_message>
<xml_diff>
--- a/docs/dogfood/nodeslide-domain-v1/nodeslide-golden.pptx
+++ b/docs/dogfood/nodeslide-domain-v1/nodeslide-golden.pptx
@@ -511,7 +511,7 @@
               <a:t>Narrative role: NodeSlide / 01. Keep the spoken transition focused on “Build the story. Keep every decision editable.”
 Evidence note: Content is based on the supplied creation brief. Illustrative examples are not independently verified; replace them with measured evidence before external publication.
 NodeSlide sources
-[source_96a6a42be4bdf0cef8b6f3f8c453dbfb] NodeSlide product brief
+[source_fe3f18f3463dcd91585199a0d62f9eff] NodeSlide product brief
 Citation: Show how NodeSlide turns presentation work into a traceable, editable, reviewable system.
 Disclaimer: Internal working material</a:t>
             </a:r>
@@ -604,10 +604,10 @@
               <a:t>Narrative role: Scenario / 02. Keep the spoken transition focused on “Keep source context attached as the story moves.”
 Evidence note: Content is based on the supplied creation brief. Illustrative examples are not independently verified; replace them with measured evidence before external publication.
 NodeSlide sources
-[source_96a6a42be4bdf0cef8b6f3f8c453dbfb] NodeSlide product brief
+[source_fe3f18f3463dcd91585199a0d62f9eff] NodeSlide product brief
 Citation: Show how NodeSlide turns presentation work into a traceable, editable, reviewable system.
 Disclaimer: Internal working material
-[source_af6acf1aa730a0e091a9f391a61fcd2d] Golden workflow scenario
+[source_cdf31d0bdc30c453c8c14d285e0f87bf] Golden workflow scenario
 Citation: Qualitative product-workflow scenario for demonstrating NodeSlide; no measured customer benchmark is claimed.
 Disclaimer: Internal working material</a:t>
             </a:r>
@@ -700,7 +700,7 @@
               <a:t>Narrative role: Foundation / 03. Keep the spoken transition focused on “Structure turns a visual artifact into an operating surface.”
 Evidence note: Content is based on the supplied creation brief. Illustrative examples are not independently verified; replace them with measured evidence before external publication.
 NodeSlide sources
-[source_96a6a42be4bdf0cef8b6f3f8c453dbfb] NodeSlide product brief
+[source_fe3f18f3463dcd91585199a0d62f9eff] NodeSlide product brief
 Citation: Show how NodeSlide turns presentation work into a traceable, editable, reviewable system.
 Disclaimer: Internal working material</a:t>
             </a:r>
@@ -793,7 +793,7 @@
               <a:t>Narrative role: Workflow / 04. Keep the spoken transition focused on “Plan → propose → commit, with scope checked at every boundary.”
 Evidence note: Content is based on the supplied creation brief. Illustrative examples are not independently verified; replace them with measured evidence before external publication.
 NodeSlide sources
-[source_96a6a42be4bdf0cef8b6f3f8c453dbfb] NodeSlide product brief
+[source_fe3f18f3463dcd91585199a0d62f9eff] NodeSlide product brief
 Citation: Show how NodeSlide turns presentation work into a traceable, editable, reviewable system.
 Disclaimer: Internal working material</a:t>
             </a:r>
@@ -886,10 +886,10 @@
               <a:t>Narrative role: Proof / 05. Keep the spoken transition focused on “A beautiful deck still needs deterministic gates.”
 Evidence note: Content is based on the supplied creation brief. Illustrative examples are not independently verified; replace them with measured evidence before external publication.
 NodeSlide sources
-[source_96a6a42be4bdf0cef8b6f3f8c453dbfb] NodeSlide product brief
+[source_fe3f18f3463dcd91585199a0d62f9eff] NodeSlide product brief
 Citation: Show how NodeSlide turns presentation work into a traceable, editable, reviewable system.
 Disclaimer: Internal working material
-[source_af6acf1aa730a0e091a9f391a61fcd2d] Golden workflow scenario
+[source_cdf31d0bdc30c453c8c14d285e0f87bf] Golden workflow scenario
 Citation: Qualitative product-workflow scenario for demonstrating NodeSlide; no measured customer benchmark is claimed.
 Disclaimer: Internal working material</a:t>
             </a:r>
@@ -982,7 +982,7 @@
               <a:t>Narrative role: Trust / 06. Keep the spoken transition focused on “Comments become context. Patches remain choices.”
 Evidence note: Content is based on the supplied creation brief. Illustrative examples are not independently verified; replace them with measured evidence before external publication.
 NodeSlide sources
-[source_96a6a42be4bdf0cef8b6f3f8c453dbfb] NodeSlide product brief
+[source_fe3f18f3463dcd91585199a0d62f9eff] NodeSlide product brief
 Citation: Show how NodeSlide turns presentation work into a traceable, editable, reviewable system.
 Disclaimer: Internal working material</a:t>
             </a:r>
@@ -1075,7 +1075,7 @@
               <a:t>Narrative role: Next / 07. Keep the spoken transition focused on “Move at presentation speed without giving up engineering-grade trust.”
 Evidence note: Content is based on the supplied creation brief. Illustrative examples are not independently verified; replace them with measured evidence before external publication.
 NodeSlide sources
-[source_96a6a42be4bdf0cef8b6f3f8c453dbfb] NodeSlide product brief
+[source_fe3f18f3463dcd91585199a0d62f9eff] NodeSlide product brief
 Citation: Show how NodeSlide turns presentation work into a traceable, editable, reviewable system.
 Disclaimer: Internal working material</a:t>
             </a:r>
@@ -1452,7 +1452,7 @@
       </p:grpSpPr>
       <p:sp>
         <p:nvSpPr>
-          <p:cNvPr id="2" name="element_370ba551ddbd0662d7fc04acd744609e"/>
+          <p:cNvPr id="2" name="element_53b47f7716ac7ee776b60dc98b6c44a3"/>
           <p:cNvSpPr/>
           <p:nvPr/>
         </p:nvSpPr>
@@ -1479,7 +1479,7 @@
       </p:sp>
       <p:sp>
         <p:nvSpPr>
-          <p:cNvPr id="3" name="element_2a17a5661c042a04a73ecdc0813e2cdb"/>
+          <p:cNvPr id="3" name="element_66e80d5e2b81ef916f8835f547d706d3"/>
           <p:cNvSpPr txBox="1"/>
           <p:nvPr/>
         </p:nvSpPr>
@@ -1523,7 +1523,7 @@
       </p:sp>
       <p:sp>
         <p:nvSpPr>
-          <p:cNvPr id="4" name="element_61ee0f53c258556cd84cfd7bac8aae3a"/>
+          <p:cNvPr id="4" name="element_349c18e5b264cb65bae0730d88074d1c"/>
           <p:cNvSpPr txBox="1"/>
           <p:nvPr/>
         </p:nvSpPr>
@@ -1567,7 +1567,7 @@
       </p:sp>
       <p:sp>
         <p:nvSpPr>
-          <p:cNvPr id="5" name="element_889fb4fc4d96b7c0851e9fcfd46a6bdc"/>
+          <p:cNvPr id="5" name="element_f7c0240db9c7ebd58b411e85a657754f"/>
           <p:cNvSpPr txBox="1"/>
           <p:nvPr/>
         </p:nvSpPr>
@@ -1611,7 +1611,7 @@
       </p:sp>
       <p:sp>
         <p:nvSpPr>
-          <p:cNvPr id="6" name="element_640b14d5f6930f912de30905268178b8"/>
+          <p:cNvPr id="6" name="element_d1bdecc8294567284b5905502c7a7c41"/>
           <p:cNvSpPr txBox="1"/>
           <p:nvPr/>
         </p:nvSpPr>
@@ -1655,7 +1655,7 @@
       </p:sp>
       <p:sp>
         <p:nvSpPr>
-          <p:cNvPr id="7" name="element_c26b53ad82326babcb864b1713b5a8f0"/>
+          <p:cNvPr id="7" name="element_2e4f2c69c89f5d8b8e430a46fb18de26"/>
           <p:cNvSpPr txBox="1"/>
           <p:nvPr/>
         </p:nvSpPr>
@@ -1699,7 +1699,7 @@
       </p:sp>
       <p:sp>
         <p:nvSpPr>
-          <p:cNvPr id="8" name="element_8ea417e51d2186a7e95e517038fc0b91"/>
+          <p:cNvPr id="8" name="element_71a52c1059eb45d6c2cdf88dc6fc4857"/>
           <p:cNvSpPr txBox="1"/>
           <p:nvPr/>
         </p:nvSpPr>
@@ -1743,7 +1743,7 @@
       </p:sp>
       <p:sp>
         <p:nvSpPr>
-          <p:cNvPr id="9" name="element_a3e163e2e0e15fdee5f2c6cabeec87c5"/>
+          <p:cNvPr id="9" name="element_9aa0ef692abcc00b9331a3ead8fe1f7b"/>
           <p:cNvSpPr txBox="1"/>
           <p:nvPr/>
         </p:nvSpPr>
@@ -1787,7 +1787,7 @@
       </p:sp>
       <p:sp>
         <p:nvSpPr>
-          <p:cNvPr id="10" name="element_9f8bf6a787f0475c7a366fd188ce022e"/>
+          <p:cNvPr id="10" name="element_d4b8594043f56a9be200a1b811f8d83d"/>
           <p:cNvSpPr txBox="1"/>
           <p:nvPr/>
         </p:nvSpPr>
@@ -1863,7 +1863,7 @@
       </p:grpSpPr>
       <p:sp>
         <p:nvSpPr>
-          <p:cNvPr id="2" name="element_0323b6c8041a56d2e1a0f15fa191f2d0"/>
+          <p:cNvPr id="2" name="element_cbcc8de14cb7481c51229c1af336a05f"/>
           <p:cNvSpPr/>
           <p:nvPr/>
         </p:nvSpPr>
@@ -1890,7 +1890,7 @@
       </p:sp>
       <p:sp>
         <p:nvSpPr>
-          <p:cNvPr id="3" name="element_4b4d1dc69245682e345b15e626972fd9"/>
+          <p:cNvPr id="3" name="element_832b2226326dc765766ed6882c405f61"/>
           <p:cNvSpPr txBox="1"/>
           <p:nvPr/>
         </p:nvSpPr>
@@ -1934,7 +1934,7 @@
       </p:sp>
       <p:sp>
         <p:nvSpPr>
-          <p:cNvPr id="4" name="element_789778442a6ae438cd0ecb197d98edaf"/>
+          <p:cNvPr id="4" name="element_2a053b0990de5a774a4dba0578cda7da"/>
           <p:cNvSpPr txBox="1"/>
           <p:nvPr/>
         </p:nvSpPr>
@@ -1978,7 +1978,7 @@
       </p:sp>
       <p:sp>
         <p:nvSpPr>
-          <p:cNvPr id="5" name="element_f995c27b8b789b00520e356587acd4f5"/>
+          <p:cNvPr id="5" name="element_40334008af738053147f12e7af8f088c"/>
           <p:cNvSpPr txBox="1"/>
           <p:nvPr/>
         </p:nvSpPr>
@@ -2022,7 +2022,7 @@
       </p:sp>
       <p:sp>
         <p:nvSpPr>
-          <p:cNvPr id="6" name="element_ec3dd98375c7ad4afedf99c4c93224c9"/>
+          <p:cNvPr id="6" name="element_4e167ccdb490292c7b0fba15a315ecef"/>
           <p:cNvSpPr txBox="1"/>
           <p:nvPr/>
         </p:nvSpPr>
@@ -2066,7 +2066,7 @@
       </p:sp>
       <p:sp>
         <p:nvSpPr>
-          <p:cNvPr id="7" name="element_d78f82eb60b33b82068b8455e74a04e7"/>
+          <p:cNvPr id="7" name="element_bd69d5283543b3fb21ae6483a302d4d7"/>
           <p:cNvSpPr txBox="1"/>
           <p:nvPr/>
         </p:nvSpPr>
@@ -2110,7 +2110,7 @@
       </p:sp>
       <p:sp>
         <p:nvSpPr>
-          <p:cNvPr id="8" name="element_a7d2620b40de0c871dfe92184d50a0da"/>
+          <p:cNvPr id="8" name="element_c7fbd294d269b565c5f2bcae80df495b"/>
           <p:cNvSpPr txBox="1"/>
           <p:nvPr/>
         </p:nvSpPr>
@@ -2154,7 +2154,7 @@
       </p:sp>
       <p:sp>
         <p:nvSpPr>
-          <p:cNvPr id="9" name="element_bec6c837aaac7a129e0d827ac1c37b61"/>
+          <p:cNvPr id="9" name="element_4d99e843358969f04da70874256da0b1"/>
           <p:cNvSpPr txBox="1"/>
           <p:nvPr/>
         </p:nvSpPr>
@@ -2198,7 +2198,7 @@
       </p:sp>
       <p:sp>
         <p:nvSpPr>
-          <p:cNvPr id="10" name="element_58305a50bc1379606692fa40c8a074f7"/>
+          <p:cNvPr id="10" name="element_225bc32d00a91bbe4b5d246eb1aa26d1"/>
           <p:cNvSpPr txBox="1"/>
           <p:nvPr/>
         </p:nvSpPr>
@@ -2242,7 +2242,7 @@
       </p:sp>
       <p:sp>
         <p:nvSpPr>
-          <p:cNvPr id="11" name="element_49bbb381be7ee11d3d18ed0dc590f285"/>
+          <p:cNvPr id="11" name="element_c13faa5abad08aecc5282aed3dc1f672"/>
           <p:cNvSpPr txBox="1"/>
           <p:nvPr/>
         </p:nvSpPr>
@@ -2286,7 +2286,7 @@
       </p:sp>
       <p:sp>
         <p:nvSpPr>
-          <p:cNvPr id="12" name="element_6d0bbd1eb433fb6fb13804987f4defac"/>
+          <p:cNvPr id="12" name="element_7d3cbd704f6c42e0ec9efe2f5cb50a8a"/>
           <p:cNvSpPr txBox="1"/>
           <p:nvPr/>
         </p:nvSpPr>
@@ -2362,7 +2362,7 @@
       </p:grpSpPr>
       <p:sp>
         <p:nvSpPr>
-          <p:cNvPr id="2" name="element_bec4971c774830d322c8800996c91d15"/>
+          <p:cNvPr id="2" name="element_3647a6b20b587bdbb12ae59305dee26b"/>
           <p:cNvSpPr/>
           <p:nvPr/>
         </p:nvSpPr>
@@ -2389,7 +2389,7 @@
       </p:sp>
       <p:sp>
         <p:nvSpPr>
-          <p:cNvPr id="3" name="element_9c7d118eeb0028bb5880c62920e5a089"/>
+          <p:cNvPr id="3" name="element_43fd065848fe8d854b5a4ae14bcf6686"/>
           <p:cNvSpPr txBox="1"/>
           <p:nvPr/>
         </p:nvSpPr>
@@ -2433,7 +2433,7 @@
       </p:sp>
       <p:sp>
         <p:nvSpPr>
-          <p:cNvPr id="4" name="element_d2e261320b23e4ddf307ef0fb53488d4"/>
+          <p:cNvPr id="4" name="element_6d402bdba9ed12a19bd42efc3fc9bd1e"/>
           <p:cNvSpPr txBox="1"/>
           <p:nvPr/>
         </p:nvSpPr>
@@ -2477,7 +2477,7 @@
       </p:sp>
       <p:sp>
         <p:nvSpPr>
-          <p:cNvPr id="5" name="element_da270d84c46dd7c5bce42ba37f577254"/>
+          <p:cNvPr id="5" name="element_db2264064c280e50d2eb7751d12ad471"/>
           <p:cNvSpPr txBox="1"/>
           <p:nvPr/>
         </p:nvSpPr>
@@ -2521,7 +2521,7 @@
       </p:sp>
       <p:sp>
         <p:nvSpPr>
-          <p:cNvPr id="6" name="element_06d60c7fbdfbe103ea70639b3db92a7d"/>
+          <p:cNvPr id="6" name="element_2a2624b7e1e658b405bc07bb10b5cee3"/>
           <p:cNvSpPr txBox="1"/>
           <p:nvPr/>
         </p:nvSpPr>
@@ -2565,7 +2565,7 @@
       </p:sp>
       <p:sp>
         <p:nvSpPr>
-          <p:cNvPr id="7" name="element_c7aa8c8046d17a311528f21e2b95e36e"/>
+          <p:cNvPr id="7" name="element_bd7374a44f1ec979fdd8f069c158da7c"/>
           <p:cNvSpPr txBox="1"/>
           <p:nvPr/>
         </p:nvSpPr>
@@ -2609,7 +2609,7 @@
       </p:sp>
       <p:sp>
         <p:nvSpPr>
-          <p:cNvPr id="8" name="element_0b696b9755f7429a38de3545757aba7c"/>
+          <p:cNvPr id="8" name="element_0d534e0069da27efafdd1bf9b5430ca4"/>
           <p:cNvSpPr txBox="1"/>
           <p:nvPr/>
         </p:nvSpPr>
@@ -2653,7 +2653,7 @@
       </p:sp>
       <p:sp>
         <p:nvSpPr>
-          <p:cNvPr id="9" name="element_31f1755c6c5321dfbda16c9e3b588f14"/>
+          <p:cNvPr id="9" name="element_fc8710ce90ca0f1dec56695b94ce2d21"/>
           <p:cNvSpPr txBox="1"/>
           <p:nvPr/>
         </p:nvSpPr>
@@ -2697,7 +2697,7 @@
       </p:sp>
       <p:sp>
         <p:nvSpPr>
-          <p:cNvPr id="10" name="element_53f040e31851467ba9d854f51138633f"/>
+          <p:cNvPr id="10" name="element_ba0cb98647b302edc5c2fb15794534d7"/>
           <p:cNvSpPr txBox="1"/>
           <p:nvPr/>
         </p:nvSpPr>
@@ -2773,7 +2773,7 @@
       </p:grpSpPr>
       <p:sp>
         <p:nvSpPr>
-          <p:cNvPr id="2" name="element_f6b8788565cb251e9f900665cce2b24a"/>
+          <p:cNvPr id="2" name="element_1c1be18343a0f638d3b0588a8b7f3124"/>
           <p:cNvSpPr/>
           <p:nvPr/>
         </p:nvSpPr>
@@ -2800,7 +2800,7 @@
       </p:sp>
       <p:sp>
         <p:nvSpPr>
-          <p:cNvPr id="3" name="element_9351049bb3f96171b9309cba42e89e07"/>
+          <p:cNvPr id="3" name="element_40f2507663d2717ac27a77f51bb1e5e4"/>
           <p:cNvSpPr txBox="1"/>
           <p:nvPr/>
         </p:nvSpPr>
@@ -2844,7 +2844,7 @@
       </p:sp>
       <p:sp>
         <p:nvSpPr>
-          <p:cNvPr id="4" name="element_a6b90c2ad4ed46223d3e0bc6a6566578"/>
+          <p:cNvPr id="4" name="element_66ff8fc9034013e53d12d31b8131840a"/>
           <p:cNvSpPr txBox="1"/>
           <p:nvPr/>
         </p:nvSpPr>
@@ -2888,7 +2888,7 @@
       </p:sp>
       <p:sp>
         <p:nvSpPr>
-          <p:cNvPr id="5" name="element_506193c9ec6a6c785a9803ff99dba72e"/>
+          <p:cNvPr id="5" name="element_e9be460b5c4f49085481a78efbc0c0f7"/>
           <p:cNvSpPr txBox="1"/>
           <p:nvPr/>
         </p:nvSpPr>
@@ -2932,7 +2932,7 @@
       </p:sp>
       <p:sp>
         <p:nvSpPr>
-          <p:cNvPr id="6" name="element_cba11e0475d3187ee26d88aaab74e101"/>
+          <p:cNvPr id="6" name="element_ad3ecacdd1c141637eb417fc6746a1ee"/>
           <p:cNvSpPr txBox="1"/>
           <p:nvPr/>
         </p:nvSpPr>
@@ -2976,7 +2976,7 @@
       </p:sp>
       <p:sp>
         <p:nvSpPr>
-          <p:cNvPr id="7" name="element_5b4ec81acec3013b22296cb1b010c360"/>
+          <p:cNvPr id="7" name="element_f403681ef0f5833b7d0b7f6b55baf02f"/>
           <p:cNvSpPr txBox="1"/>
           <p:nvPr/>
         </p:nvSpPr>
@@ -3020,7 +3020,7 @@
       </p:sp>
       <p:sp>
         <p:nvSpPr>
-          <p:cNvPr id="8" name="element_c001fe50024c88556ea59c3353469d9e"/>
+          <p:cNvPr id="8" name="element_3301b22f6dfdd33fb4d9a7f1ee4379b9"/>
           <p:cNvSpPr txBox="1"/>
           <p:nvPr/>
         </p:nvSpPr>
@@ -3064,7 +3064,7 @@
       </p:sp>
       <p:sp>
         <p:nvSpPr>
-          <p:cNvPr id="9" name="element_18c625c59a81b8210af639abfc6c22ef"/>
+          <p:cNvPr id="9" name="element_19bf74ea977cba1d6ea974e5b0561610"/>
           <p:cNvSpPr txBox="1"/>
           <p:nvPr/>
         </p:nvSpPr>
@@ -3108,7 +3108,7 @@
       </p:sp>
       <p:sp>
         <p:nvSpPr>
-          <p:cNvPr id="10" name="element_5568eb63bd88d552e2bb065bfadc4332"/>
+          <p:cNvPr id="10" name="element_2227e14e2c08b3d20ba1b2416440d3fc"/>
           <p:cNvSpPr txBox="1"/>
           <p:nvPr/>
         </p:nvSpPr>
@@ -3184,7 +3184,7 @@
       </p:grpSpPr>
       <p:sp>
         <p:nvSpPr>
-          <p:cNvPr id="2" name="element_451bceb6b76b18cbbaf54ad5c83f3d61"/>
+          <p:cNvPr id="2" name="element_6c59da1c9425b8d2937c8a23fa4538f9"/>
           <p:cNvSpPr/>
           <p:nvPr/>
         </p:nvSpPr>
@@ -3211,7 +3211,7 @@
       </p:sp>
       <p:sp>
         <p:nvSpPr>
-          <p:cNvPr id="3" name="element_99dde8cdfacad0ef4ac0fc63503dbc3a"/>
+          <p:cNvPr id="3" name="element_f062dabc9bf1deb419aff68f46ea022c"/>
           <p:cNvSpPr txBox="1"/>
           <p:nvPr/>
         </p:nvSpPr>
@@ -3255,7 +3255,7 @@
       </p:sp>
       <p:sp>
         <p:nvSpPr>
-          <p:cNvPr id="4" name="element_ba049b6f37f1e86df6b17725709d980f"/>
+          <p:cNvPr id="4" name="element_9cf22a76d2c6486c863f73f6a59a1225"/>
           <p:cNvSpPr txBox="1"/>
           <p:nvPr/>
         </p:nvSpPr>
@@ -3299,7 +3299,7 @@
       </p:sp>
       <p:sp>
         <p:nvSpPr>
-          <p:cNvPr id="5" name="element_9941ba7e56fe225cc28ada1ec419c89a"/>
+          <p:cNvPr id="5" name="element_c3c93b3900b0ab2846fac09c8068db23"/>
           <p:cNvSpPr txBox="1"/>
           <p:nvPr/>
         </p:nvSpPr>
@@ -3343,7 +3343,7 @@
       </p:sp>
       <p:sp>
         <p:nvSpPr>
-          <p:cNvPr id="6" name="element_6cec29e04e5c73893f580d03152a243c"/>
+          <p:cNvPr id="6" name="element_c6fdf159c7579e5e5e34bde7db2af42c"/>
           <p:cNvSpPr txBox="1"/>
           <p:nvPr/>
         </p:nvSpPr>
@@ -3387,7 +3387,7 @@
       </p:sp>
       <p:sp>
         <p:nvSpPr>
-          <p:cNvPr id="7" name="element_ce0b20446094bcd0b863bdffc4dae02e"/>
+          <p:cNvPr id="7" name="element_2767722c982282015c119479cc633ca0"/>
           <p:cNvSpPr txBox="1"/>
           <p:nvPr/>
         </p:nvSpPr>
@@ -3431,7 +3431,7 @@
       </p:sp>
       <p:sp>
         <p:nvSpPr>
-          <p:cNvPr id="8" name="element_125aaa95bae681824dc1e50a8a43ac17"/>
+          <p:cNvPr id="8" name="element_ae9fff346f77b8b6b4eb92152c9dce10"/>
           <p:cNvSpPr txBox="1"/>
           <p:nvPr/>
         </p:nvSpPr>
@@ -3475,7 +3475,7 @@
       </p:sp>
       <p:sp>
         <p:nvSpPr>
-          <p:cNvPr id="9" name="element_95f0120403f5e8fe2a139185dd62d031"/>
+          <p:cNvPr id="9" name="element_718abc118afcc1683aad02b5bb2e4ed8"/>
           <p:cNvSpPr txBox="1"/>
           <p:nvPr/>
         </p:nvSpPr>
@@ -3519,7 +3519,7 @@
       </p:sp>
       <p:sp>
         <p:nvSpPr>
-          <p:cNvPr id="10" name="element_966e6fa55884f04f4a7106777cf59f41"/>
+          <p:cNvPr id="10" name="element_9dae0dd68d5ea9b727b2144d18dc0224"/>
           <p:cNvSpPr txBox="1"/>
           <p:nvPr/>
         </p:nvSpPr>
@@ -3563,7 +3563,7 @@
       </p:sp>
       <p:sp>
         <p:nvSpPr>
-          <p:cNvPr id="11" name="element_0977339f5074d3a99ce6fe87af536bcf"/>
+          <p:cNvPr id="11" name="element_34b89ff3bb1701c41cd6ed807d1b96a0"/>
           <p:cNvSpPr txBox="1"/>
           <p:nvPr/>
         </p:nvSpPr>
@@ -3607,7 +3607,7 @@
       </p:sp>
       <p:sp>
         <p:nvSpPr>
-          <p:cNvPr id="12" name="element_dbf8f3dd75da823a23ca0bd2668e0b2f"/>
+          <p:cNvPr id="12" name="element_a3a8636f20b8117af7d3e4ce6bb9ba45"/>
           <p:cNvSpPr txBox="1"/>
           <p:nvPr/>
         </p:nvSpPr>
@@ -3683,7 +3683,7 @@
       </p:grpSpPr>
       <p:sp>
         <p:nvSpPr>
-          <p:cNvPr id="2" name="element_19ca8687bba076db065468bdc6bddfe5"/>
+          <p:cNvPr id="2" name="element_800b2f113b338f30bd9a870c07d15a37"/>
           <p:cNvSpPr/>
           <p:nvPr/>
         </p:nvSpPr>
@@ -3710,7 +3710,7 @@
       </p:sp>
       <p:sp>
         <p:nvSpPr>
-          <p:cNvPr id="3" name="element_a3663c6d987dd45a61e04186fa690b64"/>
+          <p:cNvPr id="3" name="element_830eef9a4f57f16c5d1409477dbc2e92"/>
           <p:cNvSpPr txBox="1"/>
           <p:nvPr/>
         </p:nvSpPr>
@@ -3754,7 +3754,7 @@
       </p:sp>
       <p:sp>
         <p:nvSpPr>
-          <p:cNvPr id="4" name="element_63f5e0452280dbab46f76ffcc3108a28"/>
+          <p:cNvPr id="4" name="element_c48d6a65b2b68554164e634a802ded7d"/>
           <p:cNvSpPr txBox="1"/>
           <p:nvPr/>
         </p:nvSpPr>
@@ -3798,7 +3798,7 @@
       </p:sp>
       <p:sp>
         <p:nvSpPr>
-          <p:cNvPr id="5" name="element_00a8ec2aa4d636249bf54c358eadea12"/>
+          <p:cNvPr id="5" name="element_d98dd9d286f1364587c5d1525b9b723f"/>
           <p:cNvSpPr txBox="1"/>
           <p:nvPr/>
         </p:nvSpPr>
@@ -3842,7 +3842,7 @@
       </p:sp>
       <p:sp>
         <p:nvSpPr>
-          <p:cNvPr id="6" name="element_fb5592a74423f57b348f285011258b1e"/>
+          <p:cNvPr id="6" name="element_a6f5c447aa37ce6e76fe83cd0dc87938"/>
           <p:cNvSpPr txBox="1"/>
           <p:nvPr/>
         </p:nvSpPr>
@@ -3886,7 +3886,7 @@
       </p:sp>
       <p:sp>
         <p:nvSpPr>
-          <p:cNvPr id="7" name="element_6f765e3d1b1cafb1dd15856bc5f888d4"/>
+          <p:cNvPr id="7" name="element_344edf4cc83f40fe76c1cc569ba4ed9e"/>
           <p:cNvSpPr txBox="1"/>
           <p:nvPr/>
         </p:nvSpPr>
@@ -3930,7 +3930,7 @@
       </p:sp>
       <p:sp>
         <p:nvSpPr>
-          <p:cNvPr id="8" name="element_c1ec97e61c3b3938d801a09e09c29cfc"/>
+          <p:cNvPr id="8" name="element_f2e23a39e10c391a91aa50c8b927e6a8"/>
           <p:cNvSpPr txBox="1"/>
           <p:nvPr/>
         </p:nvSpPr>
@@ -3974,7 +3974,7 @@
       </p:sp>
       <p:sp>
         <p:nvSpPr>
-          <p:cNvPr id="9" name="element_d1a3255fa93f750afd58a04ff7e48ef5"/>
+          <p:cNvPr id="9" name="element_9a8b030e5eae68f982a55a608969958f"/>
           <p:cNvSpPr txBox="1"/>
           <p:nvPr/>
         </p:nvSpPr>
@@ -4018,7 +4018,7 @@
       </p:sp>
       <p:sp>
         <p:nvSpPr>
-          <p:cNvPr id="10" name="element_85262c52b8125d6656f63c3f13fb3312"/>
+          <p:cNvPr id="10" name="element_7c2513557ea4b3f3c2d7b0089460b10e"/>
           <p:cNvSpPr txBox="1"/>
           <p:nvPr/>
         </p:nvSpPr>
@@ -4094,7 +4094,7 @@
       </p:grpSpPr>
       <p:sp>
         <p:nvSpPr>
-          <p:cNvPr id="2" name="element_ca510e1e6e4d03fa8881b2dd2f24344e"/>
+          <p:cNvPr id="2" name="element_c94d091cdc3e11e427e266892f4a4017"/>
           <p:cNvSpPr/>
           <p:nvPr/>
         </p:nvSpPr>
@@ -4121,7 +4121,7 @@
       </p:sp>
       <p:sp>
         <p:nvSpPr>
-          <p:cNvPr id="3" name="element_ef302973c8cf89f099df99ee73af225d"/>
+          <p:cNvPr id="3" name="element_7ac643218aa6bd00285c8ac93fa3ca30"/>
           <p:cNvSpPr txBox="1"/>
           <p:nvPr/>
         </p:nvSpPr>
@@ -4165,7 +4165,7 @@
       </p:sp>
       <p:sp>
         <p:nvSpPr>
-          <p:cNvPr id="4" name="element_13ca8ba036a904ea56d8bca9318afdd3"/>
+          <p:cNvPr id="4" name="element_b90864e07e3c485affc98c58f4b40234"/>
           <p:cNvSpPr txBox="1"/>
           <p:nvPr/>
         </p:nvSpPr>
@@ -4209,7 +4209,7 @@
       </p:sp>
       <p:sp>
         <p:nvSpPr>
-          <p:cNvPr id="5" name="element_d4bce2e3d3c4fc2e222c109f3e3fd619"/>
+          <p:cNvPr id="5" name="element_a8e135f63583f24efd8b955ac404e63c"/>
           <p:cNvSpPr txBox="1"/>
           <p:nvPr/>
         </p:nvSpPr>
@@ -4253,7 +4253,7 @@
       </p:sp>
       <p:sp>
         <p:nvSpPr>
-          <p:cNvPr id="6" name="element_d36588f2838c48e996792c40d6c71cd7"/>
+          <p:cNvPr id="6" name="element_68a25cb60e3026ce87be8282cc5c293e"/>
           <p:cNvSpPr txBox="1"/>
           <p:nvPr/>
         </p:nvSpPr>
@@ -4297,7 +4297,7 @@
       </p:sp>
       <p:sp>
         <p:nvSpPr>
-          <p:cNvPr id="7" name="element_ecc6b3b19966be17f0ae9a960450697b"/>
+          <p:cNvPr id="7" name="element_1e31cfa434cc9a946f89b7cc06710c96"/>
           <p:cNvSpPr txBox="1"/>
           <p:nvPr/>
         </p:nvSpPr>
@@ -4341,7 +4341,7 @@
       </p:sp>
       <p:sp>
         <p:nvSpPr>
-          <p:cNvPr id="8" name="element_7b9ccab240d4d9748a87a580267929e5"/>
+          <p:cNvPr id="8" name="element_2889b1f64385cb62dcba74677cf33e2c"/>
           <p:cNvSpPr txBox="1"/>
           <p:nvPr/>
         </p:nvSpPr>
@@ -4385,7 +4385,7 @@
       </p:sp>
       <p:sp>
         <p:nvSpPr>
-          <p:cNvPr id="9" name="element_662ef7e94e555044c2f18e59d2f57d0d"/>
+          <p:cNvPr id="9" name="element_24b34ae693595a9403db115430298cd4"/>
           <p:cNvSpPr txBox="1"/>
           <p:nvPr/>
         </p:nvSpPr>
@@ -4429,7 +4429,7 @@
       </p:sp>
       <p:sp>
         <p:nvSpPr>
-          <p:cNvPr id="10" name="element_91924c9ea1e07b25e41eb251a77b36f3"/>
+          <p:cNvPr id="10" name="element_1e0d799f00077c09182d90dda0d43f00"/>
           <p:cNvSpPr txBox="1"/>
           <p:nvPr/>
         </p:nvSpPr>

</xml_diff>